<commit_message>
folien: bilder in hoher aufloesung, icons und logo nachgeschaerft
</commit_message>
<xml_diff>
--- a/folien/00-orientierung.pptx
+++ b/folien/00-orientierung.pptx
@@ -2924,7 +2924,7 @@
       </p:grpSpPr>
       <p:pic>
         <p:nvPicPr>
-          <p:cNvPr id="2" name="Image 0" descr="/Users/jacobmenge/Desktop/kurs-unterlagen/folien/assets/icons/cloudhelden.png">    </p:cNvPr>
+          <p:cNvPr id="2" name="Image 0" descr="/Users/jacobmenge/Desktop/kurs-26.2b-orga/folienwerkstatt/assets/icons/cloudhelden.png">    </p:cNvPr>
           <p:cNvPicPr>
             <a:picLocks noChangeAspect="1"/>
           </p:cNvPicPr>
@@ -6196,7 +6196,7 @@
       </p:sp>
       <p:pic>
         <p:nvPicPr>
-          <p:cNvPr id="8" name="Image 0" descr="/Users/jacobmenge/Desktop/kurs-unterlagen/folien/assets/icons/wireshark-1679A7.png">    </p:cNvPr>
+          <p:cNvPr id="8" name="Image 0" descr="/Users/jacobmenge/Desktop/kurs-26.2b-orga/folienwerkstatt/assets/icons/wireshark-1679A7.png">    </p:cNvPr>
           <p:cNvPicPr>
             <a:picLocks noChangeAspect="1"/>
           </p:cNvPicPr>
@@ -6286,7 +6286,7 @@
       </p:sp>
       <p:pic>
         <p:nvPicPr>
-          <p:cNvPr id="11" name="Image 1" descr="/Users/jacobmenge/Desktop/kurs-unterlagen/folien/assets/icons/ubuntu-E95420.png">    </p:cNvPr>
+          <p:cNvPr id="11" name="Image 1" descr="/Users/jacobmenge/Desktop/kurs-26.2b-orga/folienwerkstatt/assets/icons/ubuntu-E95420.png">    </p:cNvPr>
           <p:cNvPicPr>
             <a:picLocks noChangeAspect="1"/>
           </p:cNvPicPr>
@@ -6376,7 +6376,7 @@
       </p:sp>
       <p:pic>
         <p:nvPicPr>
-          <p:cNvPr id="14" name="Image 2" descr="/Users/jacobmenge/Desktop/kurs-unterlagen/folien/assets/icons/docker-2496ED.png">    </p:cNvPr>
+          <p:cNvPr id="14" name="Image 2" descr="/Users/jacobmenge/Desktop/kurs-26.2b-orga/folienwerkstatt/assets/icons/docker-2496ED.png">    </p:cNvPr>
           <p:cNvPicPr>
             <a:picLocks noChangeAspect="1"/>
           </p:cNvPicPr>
@@ -6466,7 +6466,7 @@
       </p:sp>
       <p:pic>
         <p:nvPicPr>
-          <p:cNvPr id="17" name="Image 3" descr="/Users/jacobmenge/Desktop/kurs-unterlagen/folien/assets/icons/mqtt-660066.png">    </p:cNvPr>
+          <p:cNvPr id="17" name="Image 3" descr="/Users/jacobmenge/Desktop/kurs-26.2b-orga/folienwerkstatt/assets/icons/mqtt-660066.png">    </p:cNvPr>
           <p:cNvPicPr>
             <a:picLocks noChangeAspect="1"/>
           </p:cNvPicPr>
@@ -6595,7 +6595,7 @@
       </p:sp>
       <p:pic>
         <p:nvPicPr>
-          <p:cNvPr id="21" name="Image 4" descr="/Users/jacobmenge/Desktop/kurs-unterlagen/folien/assets/icons/kubernetes-326CE5.png">    </p:cNvPr>
+          <p:cNvPr id="21" name="Image 4" descr="/Users/jacobmenge/Desktop/kurs-26.2b-orga/folienwerkstatt/assets/icons/kubernetes-326CE5.png">    </p:cNvPr>
           <p:cNvPicPr>
             <a:picLocks noChangeAspect="1"/>
           </p:cNvPicPr>
@@ -6685,7 +6685,7 @@
       </p:sp>
       <p:pic>
         <p:nvPicPr>
-          <p:cNvPr id="24" name="Image 5" descr="/Users/jacobmenge/Desktop/kurs-unterlagen/folien/assets/icons/terraform-844FBA.png">    </p:cNvPr>
+          <p:cNvPr id="24" name="Image 5" descr="/Users/jacobmenge/Desktop/kurs-26.2b-orga/folienwerkstatt/assets/icons/terraform-844FBA.png">    </p:cNvPr>
           <p:cNvPicPr>
             <a:picLocks noChangeAspect="1"/>
           </p:cNvPicPr>
@@ -6775,7 +6775,7 @@
       </p:sp>
       <p:pic>
         <p:nvPicPr>
-          <p:cNvPr id="27" name="Image 6" descr="/Users/jacobmenge/Desktop/kurs-unterlagen/folien/assets/icons/grafana-F46800.png">    </p:cNvPr>
+          <p:cNvPr id="27" name="Image 6" descr="/Users/jacobmenge/Desktop/kurs-26.2b-orga/folienwerkstatt/assets/icons/grafana-F46800.png">    </p:cNvPr>
           <p:cNvPicPr>
             <a:picLocks noChangeAspect="1"/>
           </p:cNvPicPr>
@@ -6865,7 +6865,7 @@
       </p:sp>
       <p:pic>
         <p:nvPicPr>
-          <p:cNvPr id="30" name="Image 7" descr="/Users/jacobmenge/Desktop/kurs-unterlagen/folien/assets/icons/githubactions-2088FF.png">    </p:cNvPr>
+          <p:cNvPr id="30" name="Image 7" descr="/Users/jacobmenge/Desktop/kurs-26.2b-orga/folienwerkstatt/assets/icons/githubactions-2088FF.png">    </p:cNvPr>
           <p:cNvPicPr>
             <a:picLocks noChangeAspect="1"/>
           </p:cNvPicPr>
@@ -6994,7 +6994,7 @@
       </p:sp>
       <p:pic>
         <p:nvPicPr>
-          <p:cNvPr id="34" name="Image 8" descr="/Users/jacobmenge/Desktop/kurs-unterlagen/folien/assets/icons/trivy-1904DA.png">    </p:cNvPr>
+          <p:cNvPr id="34" name="Image 8" descr="/Users/jacobmenge/Desktop/kurs-26.2b-orga/folienwerkstatt/assets/icons/trivy-1904DA.png">    </p:cNvPr>
           <p:cNvPicPr>
             <a:picLocks noChangeAspect="1"/>
           </p:cNvPicPr>
@@ -7624,7 +7624,7 @@
       </p:sp>
       <p:pic>
         <p:nvPicPr>
-          <p:cNvPr id="8" name="Image 0" descr="/Users/jacobmenge/Desktop/kurs-unterlagen/folien/assets/icons/pluralsight-F15B2A.png">    </p:cNvPr>
+          <p:cNvPr id="8" name="Image 0" descr="/Users/jacobmenge/Desktop/kurs-26.2b-orga/folienwerkstatt/assets/icons/pluralsight-F15B2A.png">    </p:cNvPr>
           <p:cNvPicPr>
             <a:picLocks noChangeAspect="1"/>
           </p:cNvPicPr>
@@ -10610,7 +10610,7 @@
       </p:sp>
       <p:pic>
         <p:nvPicPr>
-          <p:cNvPr id="8" name="Image 0" descr="/Users/jacobmenge/Desktop/kurs-unterlagen/folien/assets/icons/googlemeet-00897B.png">    </p:cNvPr>
+          <p:cNvPr id="8" name="Image 0" descr="/Users/jacobmenge/Desktop/kurs-26.2b-orga/folienwerkstatt/assets/icons/googlemeet-00897B.png">    </p:cNvPr>
           <p:cNvPicPr>
             <a:picLocks noChangeAspect="1"/>
           </p:cNvPicPr>
@@ -12759,7 +12759,7 @@
       </p:sp>
       <p:pic>
         <p:nvPicPr>
-          <p:cNvPr id="12" name="Image 0" descr="/Users/jacobmenge/Desktop/kurs-unterlagen/folien/assets/icons/cloudhelden.png">    </p:cNvPr>
+          <p:cNvPr id="12" name="Image 0" descr="/Users/jacobmenge/Desktop/kurs-26.2b-orga/folienwerkstatt/assets/icons/cloudhelden.png">    </p:cNvPr>
           <p:cNvPicPr>
             <a:picLocks noChangeAspect="1"/>
           </p:cNvPicPr>
@@ -12943,7 +12943,7 @@
       </p:sp>
       <p:pic>
         <p:nvPicPr>
-          <p:cNvPr id="18" name="Image 1" descr="/Users/jacobmenge/Desktop/kurs-unterlagen/folien/assets/icons/pluralsight-F15B2A.png">    </p:cNvPr>
+          <p:cNvPr id="18" name="Image 1" descr="/Users/jacobmenge/Desktop/kurs-26.2b-orga/folienwerkstatt/assets/icons/pluralsight-F15B2A.png">    </p:cNvPr>
           <p:cNvPicPr>
             <a:picLocks noChangeAspect="1"/>
           </p:cNvPicPr>
@@ -14707,7 +14707,7 @@
       </p:sp>
       <p:pic>
         <p:nvPicPr>
-          <p:cNvPr id="6" name="Image 0" descr="/Users/jacobmenge/Desktop/kurs-unterlagen/folien/assets/jacob.jpg">    </p:cNvPr>
+          <p:cNvPr id="6" name="Image 0" descr="/Users/jacobmenge/Desktop/kurs-26.2b-orga/folienwerkstatt/assets/jacob.jpg">    </p:cNvPr>
           <p:cNvPicPr>
             <a:picLocks noChangeAspect="1"/>
           </p:cNvPicPr>

</xml_diff>